<commit_message>
Actualizacion de presentacion pptx
</commit_message>
<xml_diff>
--- a/1. DOCUMENTACION/TRIMESTRE II/DATASTOCK_PRESENTACION.pptx
+++ b/1. DOCUMENTACION/TRIMESTRE II/DATASTOCK_PRESENTACION.pptx
@@ -284,7 +284,7 @@
       </p15:sldGuideLst>
     </p:ext>
     <p:ext uri="GoogleSlidesCustomDataVersion2">
-      <go:slidesCustomData xmlns="" xmlns:mc="http://schemas.openxmlformats.org/markup-compatibility/2006" xmlns:mv="urn:schemas-microsoft-com:mac:vml" xmlns:c="http://schemas.openxmlformats.org/drawingml/2006/chart" xmlns:dgm="http://schemas.openxmlformats.org/drawingml/2006/diagram" xmlns:o="urn:schemas-microsoft-com:office:office" xmlns:v="urn:schemas-microsoft-com:vml" xmlns:pvml="urn:schemas-microsoft-com:office:powerpoint" xmlns:com="http://schemas.openxmlformats.org/drawingml/2006/compatibility" xmlns:p14="http://schemas.microsoft.com/office/powerpoint/2010/main" xmlns:p15="http://schemas.microsoft.com/office/powerpoint/2012/main" xmlns:ahyp="http://schemas.microsoft.com/office/drawing/2018/hyperlinkcolor" xmlns:go="http://customooxmlschemas.google.com/" r:id="rId33" roundtripDataSignature="AMtx7mjPZUknAHc/k+LNFLdQab6FCDQdgw=="/>
+      <go:slidesCustomData xmlns:go="http://customooxmlschemas.google.com/" xmlns:ahyp="http://schemas.microsoft.com/office/drawing/2018/hyperlinkcolor" xmlns:p15="http://schemas.microsoft.com/office/powerpoint/2012/main" xmlns:p14="http://schemas.microsoft.com/office/powerpoint/2010/main" xmlns:com="http://schemas.openxmlformats.org/drawingml/2006/compatibility" xmlns:pvml="urn:schemas-microsoft-com:office:powerpoint" xmlns:v="urn:schemas-microsoft-com:vml" xmlns:o="urn:schemas-microsoft-com:office:office" xmlns:dgm="http://schemas.openxmlformats.org/drawingml/2006/diagram" xmlns:c="http://schemas.openxmlformats.org/drawingml/2006/chart" xmlns:mv="urn:schemas-microsoft-com:mac:vml" xmlns:mc="http://schemas.openxmlformats.org/markup-compatibility/2006" xmlns="" r:id="rId33" roundtripDataSignature="AMtx7mjPZUknAHc/k+LNFLdQab6FCDQdgw=="/>
     </p:ext>
   </p:extLst>
 </p:presentation>
@@ -2273,7 +2273,7 @@
             </a:pPr>
             <a:fld id="{00000000-1234-1234-1234-123412341234}" type="slidenum">
               <a:rPr lang="es-MX"/>
-              <a:t>3</a:t>
+              <a:t>2</a:t>
             </a:fld>
             <a:endParaRPr/>
           </a:p>
@@ -2437,7 +2437,7 @@
             </a:pPr>
             <a:fld id="{00000000-1234-1234-1234-123412341234}" type="slidenum">
               <a:rPr lang="es-MX"/>
-              <a:t>2</a:t>
+              <a:t>3</a:t>
             </a:fld>
             <a:endParaRPr/>
           </a:p>
@@ -20996,21 +20996,55 @@
               <a:buNone/>
             </a:pPr>
             <a:r>
-              <a:rPr lang="es-MX">
+              <a:rPr lang="es-MX" dirty="0">
                 <a:solidFill>
-                  <a:schemeClr val="accent2"/>
+                  <a:srgbClr val="15540B"/>
                 </a:solidFill>
               </a:rPr>
               <a:t>DATA STOCK</a:t>
             </a:r>
-            <a:endParaRPr lang="es-ES">
+            <a:endParaRPr lang="es-ES" dirty="0">
               <a:solidFill>
-                <a:schemeClr val="accent2"/>
+                <a:srgbClr val="15540B"/>
               </a:solidFill>
             </a:endParaRPr>
           </a:p>
         </p:txBody>
       </p:sp>
+      <p:cxnSp>
+        <p:nvCxnSpPr>
+          <p:cNvPr id="2" name="Google Shape;201;p5">
+            <a:extLst>
+              <a:ext uri="{FF2B5EF4-FFF2-40B4-BE49-F238E27FC236}">
+                <a16:creationId xmlns:a16="http://schemas.microsoft.com/office/drawing/2014/main" id="{6A1B3BCF-1AA3-3EA3-3C4D-BF266D8B2B4D}"/>
+              </a:ext>
+            </a:extLst>
+          </p:cNvPr>
+          <p:cNvCxnSpPr>
+            <a:cxnSpLocks/>
+          </p:cNvCxnSpPr>
+          <p:nvPr/>
+        </p:nvCxnSpPr>
+        <p:spPr>
+          <a:xfrm>
+            <a:off x="726444" y="279618"/>
+            <a:ext cx="0" cy="6637939"/>
+          </a:xfrm>
+          <a:prstGeom prst="straightConnector1">
+            <a:avLst/>
+          </a:prstGeom>
+          <a:noFill/>
+          <a:ln w="38100" cap="flat" cmpd="sng">
+            <a:solidFill>
+              <a:srgbClr val="15540B"/>
+            </a:solidFill>
+            <a:prstDash val="solid"/>
+            <a:round/>
+            <a:headEnd type="none" w="med" len="med"/>
+            <a:tailEnd type="none" w="med" len="med"/>
+          </a:ln>
+        </p:spPr>
+      </p:cxnSp>
     </p:spTree>
   </p:cSld>
   <p:clrMapOvr>
@@ -22547,10 +22581,18 @@
               <a:buNone/>
             </a:pPr>
             <a:r>
-              <a:rPr lang="es-MX"/>
+              <a:rPr lang="es-MX" dirty="0">
+                <a:solidFill>
+                  <a:srgbClr val="15540B"/>
+                </a:solidFill>
+              </a:rPr>
               <a:t>DATA STOCK</a:t>
             </a:r>
-            <a:endParaRPr/>
+            <a:endParaRPr dirty="0">
+              <a:solidFill>
+                <a:srgbClr val="15540B"/>
+              </a:solidFill>
+            </a:endParaRPr>
           </a:p>
         </p:txBody>
       </p:sp>
@@ -22675,6 +22717,72 @@
           </a:prstGeom>
         </p:spPr>
       </p:pic>
+      <p:cxnSp>
+        <p:nvCxnSpPr>
+          <p:cNvPr id="2" name="Google Shape;201;p5">
+            <a:extLst>
+              <a:ext uri="{FF2B5EF4-FFF2-40B4-BE49-F238E27FC236}">
+                <a16:creationId xmlns:a16="http://schemas.microsoft.com/office/drawing/2014/main" id="{565B9D68-258E-F5B2-ECA6-E97F052AF2FC}"/>
+              </a:ext>
+            </a:extLst>
+          </p:cNvPr>
+          <p:cNvCxnSpPr/>
+          <p:nvPr/>
+        </p:nvCxnSpPr>
+        <p:spPr>
+          <a:xfrm>
+            <a:off x="11580488" y="3628357"/>
+            <a:ext cx="9900" cy="3289200"/>
+          </a:xfrm>
+          <a:prstGeom prst="straightConnector1">
+            <a:avLst/>
+          </a:prstGeom>
+          <a:noFill/>
+          <a:ln w="38100" cap="flat" cmpd="sng">
+            <a:solidFill>
+              <a:srgbClr val="15540B"/>
+            </a:solidFill>
+            <a:prstDash val="solid"/>
+            <a:round/>
+            <a:headEnd type="none" w="med" len="med"/>
+            <a:tailEnd type="none" w="med" len="med"/>
+          </a:ln>
+        </p:spPr>
+      </p:cxnSp>
+      <p:cxnSp>
+        <p:nvCxnSpPr>
+          <p:cNvPr id="4" name="Google Shape;201;p5">
+            <a:extLst>
+              <a:ext uri="{FF2B5EF4-FFF2-40B4-BE49-F238E27FC236}">
+                <a16:creationId xmlns:a16="http://schemas.microsoft.com/office/drawing/2014/main" id="{88DC73FA-16E0-678B-80B1-FB57393A4008}"/>
+              </a:ext>
+            </a:extLst>
+          </p:cNvPr>
+          <p:cNvCxnSpPr>
+            <a:cxnSpLocks/>
+          </p:cNvCxnSpPr>
+          <p:nvPr/>
+        </p:nvCxnSpPr>
+        <p:spPr>
+          <a:xfrm flipH="1" flipV="1">
+            <a:off x="0" y="813051"/>
+            <a:ext cx="7973595" cy="30"/>
+          </a:xfrm>
+          <a:prstGeom prst="straightConnector1">
+            <a:avLst/>
+          </a:prstGeom>
+          <a:noFill/>
+          <a:ln w="38100" cap="flat" cmpd="sng">
+            <a:solidFill>
+              <a:srgbClr val="15540B"/>
+            </a:solidFill>
+            <a:prstDash val="solid"/>
+            <a:round/>
+            <a:headEnd type="none" w="med" len="med"/>
+            <a:tailEnd type="none" w="med" len="med"/>
+          </a:ln>
+        </p:spPr>
+      </p:cxnSp>
     </p:spTree>
   </p:cSld>
   <p:clrMapOvr>
@@ -22814,8 +22922,8 @@
           </p:nvPr>
         </p:nvSpPr>
         <p:spPr>
-          <a:xfrm rot="-5400000">
-            <a:off x="-462628" y="1591359"/>
+          <a:xfrm>
+            <a:off x="6434400" y="5678319"/>
             <a:ext cx="3547800" cy="365100"/>
           </a:xfrm>
           <a:prstGeom prst="rect">
@@ -22842,14 +22950,14 @@
               <a:buNone/>
             </a:pPr>
             <a:r>
-              <a:rPr lang="es-MX">
+              <a:rPr lang="es-MX" dirty="0">
                 <a:solidFill>
                   <a:schemeClr val="lt1"/>
                 </a:solidFill>
               </a:rPr>
               <a:t>DATA STOCK</a:t>
             </a:r>
-            <a:endParaRPr>
+            <a:endParaRPr dirty="0">
               <a:solidFill>
                 <a:schemeClr val="lt1"/>
               </a:solidFill>
@@ -22874,8 +22982,8 @@
           </p:nvPr>
         </p:nvSpPr>
         <p:spPr>
-          <a:xfrm rot="-5400000">
-            <a:off x="-462628" y="1594242"/>
+          <a:xfrm>
+            <a:off x="6295062" y="5678319"/>
             <a:ext cx="3547800" cy="365100"/>
           </a:xfrm>
           <a:prstGeom prst="rect">
@@ -22902,14 +23010,14 @@
               <a:buNone/>
             </a:pPr>
             <a:r>
-              <a:rPr lang="es-MX">
+              <a:rPr lang="es-MX" dirty="0">
                 <a:solidFill>
                   <a:schemeClr val="lt1"/>
                 </a:solidFill>
               </a:rPr>
-              <a:t>DATA STOCK</a:t>
+              <a:t>BY: DATA STOCK</a:t>
             </a:r>
-            <a:endParaRPr>
+            <a:endParaRPr dirty="0">
               <a:solidFill>
                 <a:schemeClr val="lt1"/>
               </a:solidFill>
@@ -22935,7 +23043,7 @@
         </p:nvSpPr>
         <p:spPr>
           <a:xfrm>
-            <a:off x="3742272" y="2542594"/>
+            <a:off x="3629059" y="2542594"/>
             <a:ext cx="6847500" cy="1038000"/>
           </a:xfrm>
           <a:prstGeom prst="rect">
@@ -23001,7 +23109,7 @@
         </p:nvSpPr>
         <p:spPr>
           <a:xfrm>
-            <a:off x="6088188" y="3580600"/>
+            <a:off x="5974975" y="3580600"/>
             <a:ext cx="2419200" cy="323135"/>
           </a:xfrm>
           <a:prstGeom prst="rect">
@@ -23066,7 +23174,7 @@
         </p:nvSpPr>
         <p:spPr>
           <a:xfrm>
-            <a:off x="5741669" y="3853950"/>
+            <a:off x="5628456" y="3853950"/>
             <a:ext cx="3053100" cy="323135"/>
           </a:xfrm>
           <a:prstGeom prst="rect">
@@ -23111,13 +23219,15 @@
               </a:ext>
             </a:extLst>
           </p:cNvPr>
-          <p:cNvCxnSpPr/>
+          <p:cNvCxnSpPr>
+            <a:cxnSpLocks/>
+          </p:cNvCxnSpPr>
           <p:nvPr/>
         </p:nvCxnSpPr>
         <p:spPr>
           <a:xfrm flipH="1">
-            <a:off x="1230922" y="2393461"/>
-            <a:ext cx="58616" cy="4464538"/>
+            <a:off x="0" y="5860869"/>
+            <a:ext cx="6679474" cy="69668"/>
           </a:xfrm>
           <a:prstGeom prst="straightConnector1">
             <a:avLst/>
@@ -23164,7 +23274,7 @@
         </p:blipFill>
         <p:spPr>
           <a:xfrm>
-            <a:off x="2835256" y="2154877"/>
+            <a:off x="2722043" y="2154877"/>
             <a:ext cx="1921102" cy="2174919"/>
           </a:xfrm>
           <a:prstGeom prst="rect">

</xml_diff>